<commit_message>
more slides for account summary
</commit_message>
<xml_diff>
--- a/banking/Account Summary .pptx
+++ b/banking/Account Summary .pptx
@@ -6,11 +6,12 @@
   </p:sldMasterIdLst>
   <p:sldIdLst>
     <p:sldId id="256" r:id="rId2"/>
-    <p:sldId id="257" r:id="rId3"/>
-    <p:sldId id="258" r:id="rId4"/>
-    <p:sldId id="259" r:id="rId5"/>
-    <p:sldId id="261" r:id="rId6"/>
-    <p:sldId id="260" r:id="rId7"/>
+    <p:sldId id="262" r:id="rId3"/>
+    <p:sldId id="257" r:id="rId4"/>
+    <p:sldId id="258" r:id="rId5"/>
+    <p:sldId id="259" r:id="rId6"/>
+    <p:sldId id="261" r:id="rId7"/>
+    <p:sldId id="260" r:id="rId8"/>
   </p:sldIdLst>
   <p:sldSz cx="12192000" cy="6858000"/>
   <p:notesSz cx="6858000" cy="9144000"/>
@@ -3429,6 +3430,147 @@
           <p:cNvPr id="2" name="Title 1">
             <a:extLst>
               <a:ext uri="{FF2B5EF4-FFF2-40B4-BE49-F238E27FC236}">
+                <a16:creationId xmlns:a16="http://schemas.microsoft.com/office/drawing/2014/main" id="{65364CD4-E078-8929-D332-D3E989EFFB61}"/>
+              </a:ext>
+            </a:extLst>
+          </p:cNvPr>
+          <p:cNvSpPr>
+            <a:spLocks noGrp="1"/>
+          </p:cNvSpPr>
+          <p:nvPr>
+            <p:ph type="title"/>
+          </p:nvPr>
+        </p:nvSpPr>
+        <p:spPr/>
+        <p:txBody>
+          <a:bodyPr/>
+          <a:lstStyle/>
+          <a:p>
+            <a:r>
+              <a:rPr lang="en-US" dirty="0"/>
+              <a:t>Description	</a:t>
+            </a:r>
+          </a:p>
+        </p:txBody>
+      </p:sp>
+      <p:sp>
+        <p:nvSpPr>
+          <p:cNvPr id="3" name="Content Placeholder 2">
+            <a:extLst>
+              <a:ext uri="{FF2B5EF4-FFF2-40B4-BE49-F238E27FC236}">
+                <a16:creationId xmlns:a16="http://schemas.microsoft.com/office/drawing/2014/main" id="{35A85045-E7C1-288B-BAA6-DCE546DDD4C2}"/>
+              </a:ext>
+            </a:extLst>
+          </p:cNvPr>
+          <p:cNvSpPr>
+            <a:spLocks noGrp="1"/>
+          </p:cNvSpPr>
+          <p:nvPr>
+            <p:ph idx="1"/>
+          </p:nvPr>
+        </p:nvSpPr>
+        <p:spPr/>
+        <p:txBody>
+          <a:bodyPr/>
+          <a:lstStyle/>
+          <a:p>
+            <a:pPr marL="0" indent="0">
+              <a:buNone/>
+            </a:pPr>
+            <a:r>
+              <a:rPr lang="en-US" dirty="0"/>
+              <a:t>Build a </a:t>
+            </a:r>
+            <a:r>
+              <a:rPr lang="en-US" dirty="0" err="1"/>
+              <a:t>Dagster</a:t>
+            </a:r>
+            <a:r>
+              <a:rPr lang="en-US" dirty="0"/>
+              <a:t> and </a:t>
+            </a:r>
+            <a:r>
+              <a:rPr lang="en-US" dirty="0" err="1"/>
+              <a:t>dbt</a:t>
+            </a:r>
+            <a:r>
+              <a:rPr lang="en-US" dirty="0"/>
+              <a:t> pipeline to process bank account interest.</a:t>
+            </a:r>
+          </a:p>
+          <a:p>
+            <a:pPr marL="0" indent="0">
+              <a:buNone/>
+            </a:pPr>
+            <a:endParaRPr lang="en-US" dirty="0"/>
+          </a:p>
+        </p:txBody>
+      </p:sp>
+      <p:pic>
+        <p:nvPicPr>
+          <p:cNvPr id="4" name="Picture 3">
+            <a:extLst>
+              <a:ext uri="{FF2B5EF4-FFF2-40B4-BE49-F238E27FC236}">
+                <a16:creationId xmlns:a16="http://schemas.microsoft.com/office/drawing/2014/main" id="{687E7226-1530-B177-1DBE-7228CD9C8775}"/>
+              </a:ext>
+            </a:extLst>
+          </p:cNvPr>
+          <p:cNvPicPr>
+            <a:picLocks noChangeAspect="1"/>
+          </p:cNvPicPr>
+          <p:nvPr/>
+        </p:nvPicPr>
+        <p:blipFill>
+          <a:blip r:embed="rId2"/>
+          <a:stretch>
+            <a:fillRect/>
+          </a:stretch>
+        </p:blipFill>
+        <p:spPr>
+          <a:xfrm>
+            <a:off x="2172773" y="2437293"/>
+            <a:ext cx="5889402" cy="3874607"/>
+          </a:xfrm>
+          <a:prstGeom prst="rect">
+            <a:avLst/>
+          </a:prstGeom>
+        </p:spPr>
+      </p:pic>
+    </p:spTree>
+    <p:extLst>
+      <p:ext uri="{BB962C8B-B14F-4D97-AF65-F5344CB8AC3E}">
+        <p14:creationId xmlns:p14="http://schemas.microsoft.com/office/powerpoint/2010/main" val="2486698129"/>
+      </p:ext>
+    </p:extLst>
+  </p:cSld>
+  <p:clrMapOvr>
+    <a:masterClrMapping/>
+  </p:clrMapOvr>
+</p:sld>
+</file>
+
+<file path=ppt/slides/slide3.xml><?xml version="1.0" encoding="utf-8"?>
+<p:sld xmlns:a="http://schemas.openxmlformats.org/drawingml/2006/main" xmlns:r="http://schemas.openxmlformats.org/officeDocument/2006/relationships" xmlns:p="http://schemas.openxmlformats.org/presentationml/2006/main">
+  <p:cSld>
+    <p:spTree>
+      <p:nvGrpSpPr>
+        <p:cNvPr id="1" name=""/>
+        <p:cNvGrpSpPr/>
+        <p:nvPr/>
+      </p:nvGrpSpPr>
+      <p:grpSpPr>
+        <a:xfrm>
+          <a:off x="0" y="0"/>
+          <a:ext cx="0" cy="0"/>
+          <a:chOff x="0" y="0"/>
+          <a:chExt cx="0" cy="0"/>
+        </a:xfrm>
+      </p:grpSpPr>
+      <p:sp>
+        <p:nvSpPr>
+          <p:cNvPr id="2" name="Title 1">
+            <a:extLst>
+              <a:ext uri="{FF2B5EF4-FFF2-40B4-BE49-F238E27FC236}">
                 <a16:creationId xmlns:a16="http://schemas.microsoft.com/office/drawing/2014/main" id="{52F405A7-B515-3EB1-A2A0-E22860E1E84F}"/>
               </a:ext>
             </a:extLst>
@@ -3497,7 +3639,7 @@
 </p:sld>
 </file>
 
-<file path=ppt/slides/slide3.xml><?xml version="1.0" encoding="utf-8"?>
+<file path=ppt/slides/slide4.xml><?xml version="1.0" encoding="utf-8"?>
 <p:sld xmlns:a="http://schemas.openxmlformats.org/drawingml/2006/main" xmlns:r="http://schemas.openxmlformats.org/officeDocument/2006/relationships" xmlns:p="http://schemas.openxmlformats.org/presentationml/2006/main">
   <p:cSld>
     <p:spTree>
@@ -3621,7 +3763,7 @@
 </p:sld>
 </file>
 
-<file path=ppt/slides/slide4.xml><?xml version="1.0" encoding="utf-8"?>
+<file path=ppt/slides/slide5.xml><?xml version="1.0" encoding="utf-8"?>
 <p:sld xmlns:a="http://schemas.openxmlformats.org/drawingml/2006/main" xmlns:r="http://schemas.openxmlformats.org/officeDocument/2006/relationships" xmlns:p="http://schemas.openxmlformats.org/presentationml/2006/main">
   <p:cSld>
     <p:spTree>
@@ -3715,7 +3857,7 @@
 </p:sld>
 </file>
 
-<file path=ppt/slides/slide5.xml><?xml version="1.0" encoding="utf-8"?>
+<file path=ppt/slides/slide6.xml><?xml version="1.0" encoding="utf-8"?>
 <p:sld xmlns:a="http://schemas.openxmlformats.org/drawingml/2006/main" xmlns:r="http://schemas.openxmlformats.org/officeDocument/2006/relationships" xmlns:p="http://schemas.openxmlformats.org/presentationml/2006/main">
   <p:cSld>
     <p:spTree>
@@ -3805,7 +3947,7 @@
 </p:sld>
 </file>
 
-<file path=ppt/slides/slide6.xml><?xml version="1.0" encoding="utf-8"?>
+<file path=ppt/slides/slide7.xml><?xml version="1.0" encoding="utf-8"?>
 <p:sld xmlns:a="http://schemas.openxmlformats.org/drawingml/2006/main" xmlns:r="http://schemas.openxmlformats.org/officeDocument/2006/relationships" xmlns:p="http://schemas.openxmlformats.org/presentationml/2006/main">
   <p:cSld>
     <p:spTree>

</xml_diff>